<commit_message>
Enhance EDMS chatbot with Streamlit UI and evidence validation
</commit_message>
<xml_diff>
--- a/data/manuals/ppt/01_ED-Approval Workflow (3).pptx
+++ b/data/manuals/ppt/01_ED-Approval Workflow (3).pptx
@@ -300,7 +300,7 @@
           <a:p>
             <a:fld id="{2EAA5521-74A0-4497-BD3C-B34596D79315}" type="datetimeFigureOut">
               <a:rPr kumimoji="1" lang="ja-JP" altLang="en-US" smtClean="0"/>
-              <a:t>2025/9/23</a:t>
+              <a:t>2026/7/30</a:t>
             </a:fld>
             <a:endParaRPr kumimoji="1" lang="ja-JP" altLang="en-US"/>
           </a:p>
@@ -10985,7 +10985,7 @@
         </p:nvSpPr>
         <p:spPr>
           <a:xfrm>
-            <a:off x="180975" y="474732"/>
+            <a:off x="-113119" y="362972"/>
             <a:ext cx="7924800" cy="400110"/>
           </a:xfrm>
           <a:prstGeom prst="rect">
@@ -11015,7 +11015,21 @@
                 <a:latin typeface="Meiryo UI" panose="020B0604030504040204" pitchFamily="50" charset="-128"/>
                 <a:ea typeface="Meiryo UI" panose="020B0604030504040204" pitchFamily="50" charset="-128"/>
               </a:rPr>
-              <a:t>Enter user ID (New Approver ID) and click Delegate.</a:t>
+              <a:t>Enter user ID (New Approver ID) and </a:t>
+            </a:r>
+            <a:r>
+              <a:rPr lang="en-US" sz="1600">
+                <a:latin typeface="Meiryo UI" panose="020B0604030504040204" pitchFamily="50" charset="-128"/>
+                <a:ea typeface="Meiryo UI" panose="020B0604030504040204" pitchFamily="50" charset="-128"/>
+              </a:rPr>
+              <a:t>click on Delegate</a:t>
+            </a:r>
+            <a:r>
+              <a:rPr lang="en-US" sz="1600" dirty="0">
+                <a:latin typeface="Meiryo UI" panose="020B0604030504040204" pitchFamily="50" charset="-128"/>
+                <a:ea typeface="Meiryo UI" panose="020B0604030504040204" pitchFamily="50" charset="-128"/>
+              </a:rPr>
+              <a:t>.</a:t>
             </a:r>
             <a:endParaRPr lang="en-IN" sz="1600" dirty="0">
               <a:latin typeface="Meiryo UI" panose="020B0604030504040204" pitchFamily="50" charset="-128"/>
@@ -26076,25 +26090,15 @@
 </file>
 
 <file path=customXml/item1.xml><?xml version="1.0" encoding="utf-8"?>
-<LongProperties xmlns="http://schemas.microsoft.com/office/2006/metadata/longProperties"/>
+<?mso-contentType ?>
+<FormTemplates xmlns="http://schemas.microsoft.com/sharepoint/v3/contenttype/forms">
+  <Display>DocumentLibraryForm</Display>
+  <Edit>DocumentLibraryForm</Edit>
+  <New>DocumentLibraryForm</New>
+</FormTemplates>
 </file>
 
 <file path=customXml/item2.xml><?xml version="1.0" encoding="utf-8"?>
-<p:properties xmlns:p="http://schemas.microsoft.com/office/2006/metadata/properties" xmlns:xsi="http://www.w3.org/2001/XMLSchema-instance" xmlns:pc="http://schemas.microsoft.com/office/infopath/2007/PartnerControls">
-  <documentManagement>
-    <TaxCatchAll xmlns="ec38023c-351b-4ee8-a88e-8f6363b5466e">
-      <Value>4</Value>
-    </TaxCatchAll>
-    <_ip_UnifiedCompliancePolicyUIAction xmlns="http://schemas.microsoft.com/sharepoint/v3" xsi:nil="true"/>
-    <lcf76f155ced4ddcb4097134ff3c332f xmlns="452b68de-9366-4a6d-8b6e-45428c3cd271">
-      <Terms xmlns="http://schemas.microsoft.com/office/infopath/2007/PartnerControls"/>
-    </lcf76f155ced4ddcb4097134ff3c332f>
-    <_ip_UnifiedCompliancePolicyProperties xmlns="http://schemas.microsoft.com/sharepoint/v3" xsi:nil="true"/>
-  </documentManagement>
-</p:properties>
-</file>
-
-<file path=customXml/item3.xml><?xml version="1.0" encoding="utf-8"?>
 <ct:contentTypeSchema xmlns:ct="http://schemas.microsoft.com/office/2006/metadata/contentType" xmlns:ma="http://schemas.microsoft.com/office/2006/metadata/properties/metaAttributes" ct:_="" ma:_="" ma:contentTypeName="ドキュメント" ma:contentTypeID="0x0101006FD94448B71AFC4A8B1EBDDDC854B0DE" ma:contentTypeVersion="16" ma:contentTypeDescription="新しいドキュメントを作成します。" ma:contentTypeScope="" ma:versionID="ebda6bb7a9766a19165573f96521afa2">
   <xsd:schema xmlns:xsd="http://www.w3.org/2001/XMLSchema" xmlns:xs="http://www.w3.org/2001/XMLSchema" xmlns:p="http://schemas.microsoft.com/office/2006/metadata/properties" xmlns:ns1="http://schemas.microsoft.com/sharepoint/v3" xmlns:ns2="452b68de-9366-4a6d-8b6e-45428c3cd271" xmlns:ns3="ec38023c-351b-4ee8-a88e-8f6363b5466e" targetNamespace="http://schemas.microsoft.com/office/2006/metadata/properties" ma:root="true" ma:fieldsID="7fa6882473ca470321a00f2a5b04302e" ns1:_="" ns2:_="" ns3:_="">
     <xsd:import namespace="http://schemas.microsoft.com/sharepoint/v3"/>
@@ -26340,37 +26344,34 @@
 </ct:contentTypeSchema>
 </file>
 
+<file path=customXml/item3.xml><?xml version="1.0" encoding="utf-8"?>
+<p:properties xmlns:p="http://schemas.microsoft.com/office/2006/metadata/properties" xmlns:xsi="http://www.w3.org/2001/XMLSchema-instance" xmlns:pc="http://schemas.microsoft.com/office/infopath/2007/PartnerControls">
+  <documentManagement>
+    <TaxCatchAll xmlns="ec38023c-351b-4ee8-a88e-8f6363b5466e">
+      <Value>4</Value>
+    </TaxCatchAll>
+    <_ip_UnifiedCompliancePolicyUIAction xmlns="http://schemas.microsoft.com/sharepoint/v3" xsi:nil="true"/>
+    <lcf76f155ced4ddcb4097134ff3c332f xmlns="452b68de-9366-4a6d-8b6e-45428c3cd271">
+      <Terms xmlns="http://schemas.microsoft.com/office/infopath/2007/PartnerControls"/>
+    </lcf76f155ced4ddcb4097134ff3c332f>
+    <_ip_UnifiedCompliancePolicyProperties xmlns="http://schemas.microsoft.com/sharepoint/v3" xsi:nil="true"/>
+  </documentManagement>
+</p:properties>
+</file>
+
 <file path=customXml/item4.xml><?xml version="1.0" encoding="utf-8"?>
-<?mso-contentType ?>
-<FormTemplates xmlns="http://schemas.microsoft.com/sharepoint/v3/contenttype/forms">
-  <Display>DocumentLibraryForm</Display>
-  <Edit>DocumentLibraryForm</Edit>
-  <New>DocumentLibraryForm</New>
-</FormTemplates>
+<LongProperties xmlns="http://schemas.microsoft.com/office/2006/metadata/longProperties"/>
 </file>
 
 <file path=customXml/itemProps1.xml><?xml version="1.0" encoding="utf-8"?>
-<ds:datastoreItem xmlns:ds="http://schemas.openxmlformats.org/officeDocument/2006/customXml" ds:itemID="{1FF7788A-C23C-465D-8064-A50C91A5D78E}">
+<ds:datastoreItem xmlns:ds="http://schemas.openxmlformats.org/officeDocument/2006/customXml" ds:itemID="{C978CB5E-DCDF-4123-8B1F-4541C3EC9CD0}">
   <ds:schemaRefs>
-    <ds:schemaRef ds:uri="http://schemas.microsoft.com/office/2006/metadata/longProperties"/>
+    <ds:schemaRef ds:uri="http://schemas.microsoft.com/sharepoint/v3/contenttype/forms"/>
   </ds:schemaRefs>
 </ds:datastoreItem>
 </file>
 
 <file path=customXml/itemProps2.xml><?xml version="1.0" encoding="utf-8"?>
-<ds:datastoreItem xmlns:ds="http://schemas.openxmlformats.org/officeDocument/2006/customXml" ds:itemID="{CEDDF703-E9F5-456C-BB9E-9A3971734E17}">
-  <ds:schemaRefs>
-    <ds:schemaRef ds:uri="http://schemas.microsoft.com/office/2006/metadata/properties"/>
-    <ds:schemaRef ds:uri="http://schemas.microsoft.com/office/infopath/2007/PartnerControls"/>
-    <ds:schemaRef ds:uri="http://schemas.microsoft.com/sharepoint/v3"/>
-    <ds:schemaRef ds:uri="152c0564-0d49-45bb-8ba5-6417696b9a04"/>
-    <ds:schemaRef ds:uri="ec38023c-351b-4ee8-a88e-8f6363b5466e"/>
-    <ds:schemaRef ds:uri="452b68de-9366-4a6d-8b6e-45428c3cd271"/>
-  </ds:schemaRefs>
-</ds:datastoreItem>
-</file>
-
-<file path=customXml/itemProps3.xml><?xml version="1.0" encoding="utf-8"?>
 <ds:datastoreItem xmlns:ds="http://schemas.openxmlformats.org/officeDocument/2006/customXml" ds:itemID="{D1D1000A-46E5-40DF-AA06-77A773C2ECC6}">
   <ds:schemaRefs>
     <ds:schemaRef ds:uri="http://schemas.microsoft.com/office/2006/metadata/contentType"/>
@@ -26390,10 +26391,23 @@
 </ds:datastoreItem>
 </file>
 
+<file path=customXml/itemProps3.xml><?xml version="1.0" encoding="utf-8"?>
+<ds:datastoreItem xmlns:ds="http://schemas.openxmlformats.org/officeDocument/2006/customXml" ds:itemID="{CEDDF703-E9F5-456C-BB9E-9A3971734E17}">
+  <ds:schemaRefs>
+    <ds:schemaRef ds:uri="http://schemas.microsoft.com/office/2006/metadata/properties"/>
+    <ds:schemaRef ds:uri="http://schemas.microsoft.com/office/infopath/2007/PartnerControls"/>
+    <ds:schemaRef ds:uri="http://schemas.microsoft.com/sharepoint/v3"/>
+    <ds:schemaRef ds:uri="152c0564-0d49-45bb-8ba5-6417696b9a04"/>
+    <ds:schemaRef ds:uri="ec38023c-351b-4ee8-a88e-8f6363b5466e"/>
+    <ds:schemaRef ds:uri="452b68de-9366-4a6d-8b6e-45428c3cd271"/>
+  </ds:schemaRefs>
+</ds:datastoreItem>
+</file>
+
 <file path=customXml/itemProps4.xml><?xml version="1.0" encoding="utf-8"?>
-<ds:datastoreItem xmlns:ds="http://schemas.openxmlformats.org/officeDocument/2006/customXml" ds:itemID="{C978CB5E-DCDF-4123-8B1F-4541C3EC9CD0}">
+<ds:datastoreItem xmlns:ds="http://schemas.openxmlformats.org/officeDocument/2006/customXml" ds:itemID="{1FF7788A-C23C-465D-8064-A50C91A5D78E}">
   <ds:schemaRefs>
-    <ds:schemaRef ds:uri="http://schemas.microsoft.com/sharepoint/v3/contenttype/forms"/>
+    <ds:schemaRef ds:uri="http://schemas.microsoft.com/office/2006/metadata/longProperties"/>
   </ds:schemaRefs>
 </ds:datastoreItem>
 </file>

</xml_diff>